<commit_message>
feat(slides): May 2026 refresh + intermediate-content-polish (004)
- Flatten slides/dist/{pdf,pptx,html}/ (remove audience subtrees).
- Drop off-agenda beginner decks from slides/ tree.
- Add speaker slide (Luca Berton) to Part 1.
- Constrain Concepts-slide SVG height to fit 720p frame.
- May 2026 refresh:
  - Part 1: 'Claude Code is everywhere' (terminal/IDE/desktop/web).
  - Part 5: bundled skills (/debug, /verify, /code-review, /loop, /batch).
  - Part 6: '@claude in GitHub Actions' (PR review, issue-to-PR).
  - Part 9: rewritten as 'Skills, Hooks, MCP & Multi-Agent Workflows'.
  - Part 10: 'Overeager agents' safety lab (permission modes, review-before-commit).
- Theme fix: consolidate on wow-beginner.css; remove broken wow-intermediate.css
  (Marp CLI does not resolve CSS @import between --theme-set themes).
- Add intermediate/assets/ SVGs (01-10) and updated check-verbatim-blocks.sh audit.
- spec 004 artefacts under specs/004-intermediate-content-polish/.

Refs: feature 004.
</commit_message>
<xml_diff>
--- a/slides/dist/pptx/part-01-setup-mindset.pptx
+++ b/slides/dist/pptx/part-01-setup-mindset.pptx
@@ -19,9 +19,11 @@
     <p:sldId id="267" r:id="rId13"/>
     <p:sldId id="268" r:id="rId14"/>
     <p:sldId id="269" r:id="rId15"/>
+    <p:sldId id="270" r:id="rId16"/>
+    <p:sldId id="271" r:id="rId17"/>
   </p:sldIdLst>
   <p:notesMasterIdLst>
-    <p:notesMasterId r:id="rId16"/>
+    <p:notesMasterId r:id="rId18"/>
   </p:notesMasterIdLst>
   <p:sldSz cx="12192000" cy="6858000"/>
   <p:notesSz cx="6858000" cy="12192000"/>
@@ -979,6 +981,183 @@
             <a:fld id="{F7021451-1387-4CA6-816F-3879F97B5CBC}" type="slidenum">
               <a:rPr lang="en-US"/>
               <a:t>14</a:t>
+            </a:fld>
+            <a:endParaRPr lang="en-US"/>
+          </a:p>
+        </p:txBody>
+      </p:sp>
+    </p:spTree>
+    <p:extLst>
+      <p:ext uri="{BB962C8B-B14F-4D97-AF65-F5344CB8AC3E}">
+        <p14:creationId xmlns:p14="http://schemas.microsoft.com/office/powerpoint/2010/main" val="1024086991"/>
+      </p:ext>
+    </p:extLst>
+  </p:cSld>
+  <p:clrMapOvr>
+    <a:masterClrMapping/>
+  </p:clrMapOvr>
+</p:notes>
+</file>
+
+<file path=ppt/notesSlides/notesSlide15.xml><?xml version="1.0" encoding="utf-8"?>
+<p:notes xmlns:a="http://schemas.openxmlformats.org/drawingml/2006/main" xmlns:r="http://schemas.openxmlformats.org/officeDocument/2006/relationships" xmlns:p="http://schemas.openxmlformats.org/presentationml/2006/main">
+  <p:cSld>
+    <p:spTree>
+      <p:nvGrpSpPr>
+        <p:cNvPr id="1" name=""/>
+        <p:cNvGrpSpPr/>
+        <p:nvPr/>
+      </p:nvGrpSpPr>
+      <p:grpSpPr>
+        <a:xfrm>
+          <a:off x="0" y="0"/>
+          <a:ext cx="0" cy="0"/>
+          <a:chOff x="0" y="0"/>
+          <a:chExt cx="0" cy="0"/>
+        </a:xfrm>
+      </p:grpSpPr>
+      <p:sp>
+        <p:nvSpPr>
+          <p:cNvPr id="2" name="Slide Image Placeholder 1"/>
+          <p:cNvSpPr>
+            <a:spLocks noGrp="1" noRot="1" noChangeAspect="1"/>
+          </p:cNvSpPr>
+          <p:nvPr>
+            <p:ph type="sldImg"/>
+          </p:nvPr>
+        </p:nvSpPr>
+        <p:spPr/>
+      </p:sp>
+      <p:sp>
+        <p:nvSpPr>
+          <p:cNvPr id="3" name="Notes Placeholder 2"/>
+          <p:cNvSpPr>
+            <a:spLocks noGrp="1"/>
+          </p:cNvSpPr>
+          <p:nvPr>
+            <p:ph type="body" idx="1"/>
+          </p:nvPr>
+        </p:nvSpPr>
+        <p:spPr/>
+        <p:txBody>
+          <a:bodyPr/>
+          <a:lstStyle/>
+          <a:p>
+            <a:r>
+              <a:rPr lang="en-US" dirty="0"/>
+              <a:t/>
+            </a:r>
+            <a:endParaRPr lang="en-US" dirty="0"/>
+          </a:p>
+        </p:txBody>
+      </p:sp>
+      <p:sp>
+        <p:nvSpPr>
+          <p:cNvPr id="4" name="Slide Number Placeholder 3"/>
+          <p:cNvSpPr>
+            <a:spLocks noGrp="1"/>
+          </p:cNvSpPr>
+          <p:nvPr>
+            <p:ph type="sldNum" sz="quarter" idx="10"/>
+          </p:nvPr>
+        </p:nvSpPr>
+        <p:spPr/>
+        <p:txBody>
+          <a:bodyPr/>
+          <a:lstStyle/>
+          <a:p>
+            <a:fld id="{F7021451-1387-4CA6-816F-3879F97B5CBC}" type="slidenum">
+              <a:rPr lang="en-US"/>
+              <a:t>15</a:t>
+            </a:fld>
+            <a:endParaRPr lang="en-US"/>
+          </a:p>
+        </p:txBody>
+      </p:sp>
+    </p:spTree>
+    <p:extLst>
+      <p:ext uri="{BB962C8B-B14F-4D97-AF65-F5344CB8AC3E}">
+        <p14:creationId xmlns:p14="http://schemas.microsoft.com/office/powerpoint/2010/main" val="1024086991"/>
+      </p:ext>
+    </p:extLst>
+  </p:cSld>
+  <p:clrMapOvr>
+    <a:masterClrMapping/>
+  </p:clrMapOvr>
+</p:notes>
+</file>
+
+<file path=ppt/notesSlides/notesSlide16.xml><?xml version="1.0" encoding="utf-8"?>
+<p:notes xmlns:a="http://schemas.openxmlformats.org/drawingml/2006/main" xmlns:r="http://schemas.openxmlformats.org/officeDocument/2006/relationships" xmlns:p="http://schemas.openxmlformats.org/presentationml/2006/main">
+  <p:cSld>
+    <p:spTree>
+      <p:nvGrpSpPr>
+        <p:cNvPr id="1" name=""/>
+        <p:cNvGrpSpPr/>
+        <p:nvPr/>
+      </p:nvGrpSpPr>
+      <p:grpSpPr>
+        <a:xfrm>
+          <a:off x="0" y="0"/>
+          <a:ext cx="0" cy="0"/>
+          <a:chOff x="0" y="0"/>
+          <a:chExt cx="0" cy="0"/>
+        </a:xfrm>
+      </p:grpSpPr>
+      <p:sp>
+        <p:nvSpPr>
+          <p:cNvPr id="2" name="Slide Image Placeholder 1"/>
+          <p:cNvSpPr>
+            <a:spLocks noGrp="1" noRot="1" noChangeAspect="1"/>
+          </p:cNvSpPr>
+          <p:nvPr>
+            <p:ph type="sldImg"/>
+          </p:nvPr>
+        </p:nvSpPr>
+        <p:spPr/>
+      </p:sp>
+      <p:sp>
+        <p:nvSpPr>
+          <p:cNvPr id="3" name="Notes Placeholder 2"/>
+          <p:cNvSpPr>
+            <a:spLocks noGrp="1"/>
+          </p:cNvSpPr>
+          <p:nvPr>
+            <p:ph type="body" idx="1"/>
+          </p:nvPr>
+        </p:nvSpPr>
+        <p:spPr/>
+        <p:txBody>
+          <a:bodyPr/>
+          <a:lstStyle/>
+          <a:p>
+            <a:r>
+              <a:rPr lang="en-US" dirty="0"/>
+              <a:t>polish-log
+(intermediate-content-polish feature 004) — populated during US2 polish pass.</a:t>
+            </a:r>
+            <a:endParaRPr lang="en-US" dirty="0"/>
+          </a:p>
+        </p:txBody>
+      </p:sp>
+      <p:sp>
+        <p:nvSpPr>
+          <p:cNvPr id="4" name="Slide Number Placeholder 3"/>
+          <p:cNvSpPr>
+            <a:spLocks noGrp="1"/>
+          </p:cNvSpPr>
+          <p:nvPr>
+            <p:ph type="sldNum" sz="quarter" idx="10"/>
+          </p:nvPr>
+        </p:nvSpPr>
+        <p:spPr/>
+        <p:txBody>
+          <a:bodyPr/>
+          <a:lstStyle/>
+          <a:p>
+            <a:fld id="{F7021451-1387-4CA6-816F-3879F97B5CBC}" type="slidenum">
+              <a:rPr lang="en-US"/>
+              <a:t>16</a:t>
             </a:fld>
             <a:endParaRPr lang="en-US"/>
           </a:p>
@@ -2206,6 +2385,84 @@
 <file path=ppt/slides/slide14.xml><?xml version="1.0" encoding="utf-8"?>
 <p:sld xmlns:a="http://schemas.openxmlformats.org/drawingml/2006/main" xmlns:r="http://schemas.openxmlformats.org/officeDocument/2006/relationships" xmlns:p="http://schemas.openxmlformats.org/presentationml/2006/main">
   <p:cSld name="Slide 14">
+    <p:bg>
+      <p:bgPr>
+        <a:blipFill dpi="0" rotWithShape="1">
+          <a:blip r:embed="rId1">
+            <a:lum/>
+          </a:blip>
+          <a:srcRect/>
+          <a:stretch>
+            <a:fillRect/>
+          </a:stretch>
+        </a:blipFill>
+        <a:effectLst/>
+      </p:bgPr>
+    </p:bg>
+    <p:spTree>
+      <p:nvGrpSpPr>
+        <p:cNvPr id="1" name=""/>
+        <p:cNvGrpSpPr/>
+        <p:nvPr/>
+      </p:nvGrpSpPr>
+      <p:grpSpPr>
+        <a:xfrm>
+          <a:off x="0" y="0"/>
+          <a:ext cx="0" cy="0"/>
+          <a:chOff x="0" y="0"/>
+          <a:chExt cx="0" cy="0"/>
+        </a:xfrm>
+      </p:grpSpPr>
+    </p:spTree>
+  </p:cSld>
+  <p:clrMapOvr>
+    <a:masterClrMapping/>
+  </p:clrMapOvr>
+</p:sld>
+</file>
+
+<file path=ppt/slides/slide15.xml><?xml version="1.0" encoding="utf-8"?>
+<p:sld xmlns:a="http://schemas.openxmlformats.org/drawingml/2006/main" xmlns:r="http://schemas.openxmlformats.org/officeDocument/2006/relationships" xmlns:p="http://schemas.openxmlformats.org/presentationml/2006/main">
+  <p:cSld name="Slide 15">
+    <p:bg>
+      <p:bgPr>
+        <a:blipFill dpi="0" rotWithShape="1">
+          <a:blip r:embed="rId1">
+            <a:lum/>
+          </a:blip>
+          <a:srcRect/>
+          <a:stretch>
+            <a:fillRect/>
+          </a:stretch>
+        </a:blipFill>
+        <a:effectLst/>
+      </p:bgPr>
+    </p:bg>
+    <p:spTree>
+      <p:nvGrpSpPr>
+        <p:cNvPr id="1" name=""/>
+        <p:cNvGrpSpPr/>
+        <p:nvPr/>
+      </p:nvGrpSpPr>
+      <p:grpSpPr>
+        <a:xfrm>
+          <a:off x="0" y="0"/>
+          <a:ext cx="0" cy="0"/>
+          <a:chOff x="0" y="0"/>
+          <a:chExt cx="0" cy="0"/>
+        </a:xfrm>
+      </p:grpSpPr>
+    </p:spTree>
+  </p:cSld>
+  <p:clrMapOvr>
+    <a:masterClrMapping/>
+  </p:clrMapOvr>
+</p:sld>
+</file>
+
+<file path=ppt/slides/slide16.xml><?xml version="1.0" encoding="utf-8"?>
+<p:sld xmlns:a="http://schemas.openxmlformats.org/drawingml/2006/main" xmlns:r="http://schemas.openxmlformats.org/officeDocument/2006/relationships" xmlns:p="http://schemas.openxmlformats.org/presentationml/2006/main">
+  <p:cSld name="Slide 16">
     <p:bg>
       <p:bgPr>
         <a:blipFill dpi="0" rotWithShape="1">

</xml_diff>

<commit_message>
docs(slides): embed teaching diagrams in M1-M10 and add GitHub MCP live demo to M9
- Embed 10 teaching SVG diagrams (one per module) for visual reinforcement
- Add 'Connect GitHub over MCP' live-demo slide to Module 9 (least-privilege PAT, /mcp verify)
- Code blocks render white-on-black via wow-beginner.css for readability
- Rebuild all decks (pdf/pptx/html); preflight 15 PASS RC=0
</commit_message>
<xml_diff>
--- a/slides/dist/pptx/part-01-setup-mindset.pptx
+++ b/slides/dist/pptx/part-01-setup-mindset.pptx
@@ -17,14 +17,9 @@
     <p:sldId id="265" r:id="rId11"/>
     <p:sldId id="266" r:id="rId12"/>
     <p:sldId id="267" r:id="rId13"/>
-    <p:sldId id="268" r:id="rId14"/>
-    <p:sldId id="269" r:id="rId15"/>
-    <p:sldId id="270" r:id="rId16"/>
-    <p:sldId id="271" r:id="rId17"/>
-    <p:sldId id="272" r:id="rId18"/>
   </p:sldIdLst>
   <p:notesMasterIdLst>
-    <p:notesMasterId r:id="rId19"/>
+    <p:notesMasterId r:id="rId14"/>
   </p:notesMasterIdLst>
   <p:sldSz cx="12192000" cy="6858000"/>
   <p:notesSz cx="6858000" cy="12192000"/>
@@ -518,7 +513,11 @@
           <a:p>
             <a:r>
               <a:rPr lang="en-US" dirty="0"/>
-              <a:t>duration: 20 min</a:t>
+              <a:t>duration: 20 min
+SPEAKER NOTES — slide 1 (60 sec hook)
+- Welcome. Confirm everyone joined the LMS. Show today's schedule on your second screen.
+- ONE sentence: "By the end of today you'll ship 10 small projects with Claude Code."
+- DO NOT do live installs here. Pre-work is the entry condition.</a:t>
             </a:r>
             <a:endParaRPr lang="en-US" dirty="0"/>
           </a:p>
@@ -606,7 +605,10 @@
           <a:p>
             <a:r>
               <a:rPr lang="en-US" dirty="0"/>
-              <a:t/>
+              <a:t>SPEAKER NOTES — slide 9 (demo, 5 min)
+- Project this terminal full-screen, font ≥ 18pt.
+- If Claude says something wrong, DO NOT correct it silently — narrate "see, this is why we review".
+- Backup plan if Claude is slow: switch to /cost and show the token spend.</a:t>
             </a:r>
             <a:endParaRPr lang="en-US" dirty="0"/>
           </a:p>
@@ -694,7 +696,10 @@
           <a:p>
             <a:r>
               <a:rPr lang="en-US" dirty="0"/>
-              <a:t/>
+              <a:t>SPEAKER NOTES — slide 10 (hands-on, 8 min)
+- Walk the room. Catch students copy-pasting Claude verbatim — that's the rubric trap.
+- If pre-work was skipped, pair them with a neighbour; no live installs in this block.
+- 2-min warning at the 6-min mark.</a:t>
             </a:r>
             <a:endParaRPr lang="en-US" dirty="0"/>
           </a:p>
@@ -782,7 +787,15 @@
           <a:p>
             <a:r>
               <a:rPr lang="en-US" dirty="0"/>
-              <a:t/>
+              <a:t>SPEAKER NOTES — slide 11 (wrap, 1 min)
+- Show the DoD on screen for a full 30 seconds.
+- Bridge in one sentence — don't over-explain Module 2 yet.
+polish-log
+2026-05-28 · feature 005 follow-up — instructor-pacing shape.
+Flow: cover → welcome/course → instructor → Anthropic &amp; models → theory loop
+      → 3 reference slides (surfaces · slash commands · mistakes/cues)
+      → live demo → hands-on → done &amp; next.
+Instructor notes in HTML comments (visible in PPTX presenter view).</a:t>
             </a:r>
             <a:endParaRPr lang="en-US" dirty="0"/>
           </a:p>
@@ -806,447 +819,6 @@
             <a:fld id="{F7021451-1387-4CA6-816F-3879F97B5CBC}" type="slidenum">
               <a:rPr lang="en-US"/>
               <a:t>12</a:t>
-            </a:fld>
-            <a:endParaRPr lang="en-US"/>
-          </a:p>
-        </p:txBody>
-      </p:sp>
-    </p:spTree>
-    <p:extLst>
-      <p:ext uri="{BB962C8B-B14F-4D97-AF65-F5344CB8AC3E}">
-        <p14:creationId xmlns:p14="http://schemas.microsoft.com/office/powerpoint/2010/main" val="1024086991"/>
-      </p:ext>
-    </p:extLst>
-  </p:cSld>
-  <p:clrMapOvr>
-    <a:masterClrMapping/>
-  </p:clrMapOvr>
-</p:notes>
-</file>
-
-<file path=ppt/notesSlides/notesSlide13.xml><?xml version="1.0" encoding="utf-8"?>
-<p:notes xmlns:a="http://schemas.openxmlformats.org/drawingml/2006/main" xmlns:r="http://schemas.openxmlformats.org/officeDocument/2006/relationships" xmlns:p="http://schemas.openxmlformats.org/presentationml/2006/main">
-  <p:cSld>
-    <p:spTree>
-      <p:nvGrpSpPr>
-        <p:cNvPr id="1" name=""/>
-        <p:cNvGrpSpPr/>
-        <p:nvPr/>
-      </p:nvGrpSpPr>
-      <p:grpSpPr>
-        <a:xfrm>
-          <a:off x="0" y="0"/>
-          <a:ext cx="0" cy="0"/>
-          <a:chOff x="0" y="0"/>
-          <a:chExt cx="0" cy="0"/>
-        </a:xfrm>
-      </p:grpSpPr>
-      <p:sp>
-        <p:nvSpPr>
-          <p:cNvPr id="2" name="Slide Image Placeholder 1"/>
-          <p:cNvSpPr>
-            <a:spLocks noGrp="1" noRot="1" noChangeAspect="1"/>
-          </p:cNvSpPr>
-          <p:nvPr>
-            <p:ph type="sldImg"/>
-          </p:nvPr>
-        </p:nvSpPr>
-        <p:spPr/>
-      </p:sp>
-      <p:sp>
-        <p:nvSpPr>
-          <p:cNvPr id="3" name="Notes Placeholder 2"/>
-          <p:cNvSpPr>
-            <a:spLocks noGrp="1"/>
-          </p:cNvSpPr>
-          <p:nvPr>
-            <p:ph type="body" idx="1"/>
-          </p:nvPr>
-        </p:nvSpPr>
-        <p:spPr/>
-        <p:txBody>
-          <a:bodyPr/>
-          <a:lstStyle/>
-          <a:p>
-            <a:r>
-              <a:rPr lang="en-US" dirty="0"/>
-              <a:t/>
-            </a:r>
-            <a:endParaRPr lang="en-US" dirty="0"/>
-          </a:p>
-        </p:txBody>
-      </p:sp>
-      <p:sp>
-        <p:nvSpPr>
-          <p:cNvPr id="4" name="Slide Number Placeholder 3"/>
-          <p:cNvSpPr>
-            <a:spLocks noGrp="1"/>
-          </p:cNvSpPr>
-          <p:nvPr>
-            <p:ph type="sldNum" sz="quarter" idx="10"/>
-          </p:nvPr>
-        </p:nvSpPr>
-        <p:spPr/>
-        <p:txBody>
-          <a:bodyPr/>
-          <a:lstStyle/>
-          <a:p>
-            <a:fld id="{F7021451-1387-4CA6-816F-3879F97B5CBC}" type="slidenum">
-              <a:rPr lang="en-US"/>
-              <a:t>13</a:t>
-            </a:fld>
-            <a:endParaRPr lang="en-US"/>
-          </a:p>
-        </p:txBody>
-      </p:sp>
-    </p:spTree>
-    <p:extLst>
-      <p:ext uri="{BB962C8B-B14F-4D97-AF65-F5344CB8AC3E}">
-        <p14:creationId xmlns:p14="http://schemas.microsoft.com/office/powerpoint/2010/main" val="1024086991"/>
-      </p:ext>
-    </p:extLst>
-  </p:cSld>
-  <p:clrMapOvr>
-    <a:masterClrMapping/>
-  </p:clrMapOvr>
-</p:notes>
-</file>
-
-<file path=ppt/notesSlides/notesSlide14.xml><?xml version="1.0" encoding="utf-8"?>
-<p:notes xmlns:a="http://schemas.openxmlformats.org/drawingml/2006/main" xmlns:r="http://schemas.openxmlformats.org/officeDocument/2006/relationships" xmlns:p="http://schemas.openxmlformats.org/presentationml/2006/main">
-  <p:cSld>
-    <p:spTree>
-      <p:nvGrpSpPr>
-        <p:cNvPr id="1" name=""/>
-        <p:cNvGrpSpPr/>
-        <p:nvPr/>
-      </p:nvGrpSpPr>
-      <p:grpSpPr>
-        <a:xfrm>
-          <a:off x="0" y="0"/>
-          <a:ext cx="0" cy="0"/>
-          <a:chOff x="0" y="0"/>
-          <a:chExt cx="0" cy="0"/>
-        </a:xfrm>
-      </p:grpSpPr>
-      <p:sp>
-        <p:nvSpPr>
-          <p:cNvPr id="2" name="Slide Image Placeholder 1"/>
-          <p:cNvSpPr>
-            <a:spLocks noGrp="1" noRot="1" noChangeAspect="1"/>
-          </p:cNvSpPr>
-          <p:nvPr>
-            <p:ph type="sldImg"/>
-          </p:nvPr>
-        </p:nvSpPr>
-        <p:spPr/>
-      </p:sp>
-      <p:sp>
-        <p:nvSpPr>
-          <p:cNvPr id="3" name="Notes Placeholder 2"/>
-          <p:cNvSpPr>
-            <a:spLocks noGrp="1"/>
-          </p:cNvSpPr>
-          <p:nvPr>
-            <p:ph type="body" idx="1"/>
-          </p:nvPr>
-        </p:nvSpPr>
-        <p:spPr/>
-        <p:txBody>
-          <a:bodyPr/>
-          <a:lstStyle/>
-          <a:p>
-            <a:r>
-              <a:rPr lang="en-US" dirty="0"/>
-              <a:t/>
-            </a:r>
-            <a:endParaRPr lang="en-US" dirty="0"/>
-          </a:p>
-        </p:txBody>
-      </p:sp>
-      <p:sp>
-        <p:nvSpPr>
-          <p:cNvPr id="4" name="Slide Number Placeholder 3"/>
-          <p:cNvSpPr>
-            <a:spLocks noGrp="1"/>
-          </p:cNvSpPr>
-          <p:nvPr>
-            <p:ph type="sldNum" sz="quarter" idx="10"/>
-          </p:nvPr>
-        </p:nvSpPr>
-        <p:spPr/>
-        <p:txBody>
-          <a:bodyPr/>
-          <a:lstStyle/>
-          <a:p>
-            <a:fld id="{F7021451-1387-4CA6-816F-3879F97B5CBC}" type="slidenum">
-              <a:rPr lang="en-US"/>
-              <a:t>14</a:t>
-            </a:fld>
-            <a:endParaRPr lang="en-US"/>
-          </a:p>
-        </p:txBody>
-      </p:sp>
-    </p:spTree>
-    <p:extLst>
-      <p:ext uri="{BB962C8B-B14F-4D97-AF65-F5344CB8AC3E}">
-        <p14:creationId xmlns:p14="http://schemas.microsoft.com/office/powerpoint/2010/main" val="1024086991"/>
-      </p:ext>
-    </p:extLst>
-  </p:cSld>
-  <p:clrMapOvr>
-    <a:masterClrMapping/>
-  </p:clrMapOvr>
-</p:notes>
-</file>
-
-<file path=ppt/notesSlides/notesSlide15.xml><?xml version="1.0" encoding="utf-8"?>
-<p:notes xmlns:a="http://schemas.openxmlformats.org/drawingml/2006/main" xmlns:r="http://schemas.openxmlformats.org/officeDocument/2006/relationships" xmlns:p="http://schemas.openxmlformats.org/presentationml/2006/main">
-  <p:cSld>
-    <p:spTree>
-      <p:nvGrpSpPr>
-        <p:cNvPr id="1" name=""/>
-        <p:cNvGrpSpPr/>
-        <p:nvPr/>
-      </p:nvGrpSpPr>
-      <p:grpSpPr>
-        <a:xfrm>
-          <a:off x="0" y="0"/>
-          <a:ext cx="0" cy="0"/>
-          <a:chOff x="0" y="0"/>
-          <a:chExt cx="0" cy="0"/>
-        </a:xfrm>
-      </p:grpSpPr>
-      <p:sp>
-        <p:nvSpPr>
-          <p:cNvPr id="2" name="Slide Image Placeholder 1"/>
-          <p:cNvSpPr>
-            <a:spLocks noGrp="1" noRot="1" noChangeAspect="1"/>
-          </p:cNvSpPr>
-          <p:nvPr>
-            <p:ph type="sldImg"/>
-          </p:nvPr>
-        </p:nvSpPr>
-        <p:spPr/>
-      </p:sp>
-      <p:sp>
-        <p:nvSpPr>
-          <p:cNvPr id="3" name="Notes Placeholder 2"/>
-          <p:cNvSpPr>
-            <a:spLocks noGrp="1"/>
-          </p:cNvSpPr>
-          <p:nvPr>
-            <p:ph type="body" idx="1"/>
-          </p:nvPr>
-        </p:nvSpPr>
-        <p:spPr/>
-        <p:txBody>
-          <a:bodyPr/>
-          <a:lstStyle/>
-          <a:p>
-            <a:r>
-              <a:rPr lang="en-US" dirty="0"/>
-              <a:t/>
-            </a:r>
-            <a:endParaRPr lang="en-US" dirty="0"/>
-          </a:p>
-        </p:txBody>
-      </p:sp>
-      <p:sp>
-        <p:nvSpPr>
-          <p:cNvPr id="4" name="Slide Number Placeholder 3"/>
-          <p:cNvSpPr>
-            <a:spLocks noGrp="1"/>
-          </p:cNvSpPr>
-          <p:nvPr>
-            <p:ph type="sldNum" sz="quarter" idx="10"/>
-          </p:nvPr>
-        </p:nvSpPr>
-        <p:spPr/>
-        <p:txBody>
-          <a:bodyPr/>
-          <a:lstStyle/>
-          <a:p>
-            <a:fld id="{F7021451-1387-4CA6-816F-3879F97B5CBC}" type="slidenum">
-              <a:rPr lang="en-US"/>
-              <a:t>15</a:t>
-            </a:fld>
-            <a:endParaRPr lang="en-US"/>
-          </a:p>
-        </p:txBody>
-      </p:sp>
-    </p:spTree>
-    <p:extLst>
-      <p:ext uri="{BB962C8B-B14F-4D97-AF65-F5344CB8AC3E}">
-        <p14:creationId xmlns:p14="http://schemas.microsoft.com/office/powerpoint/2010/main" val="1024086991"/>
-      </p:ext>
-    </p:extLst>
-  </p:cSld>
-  <p:clrMapOvr>
-    <a:masterClrMapping/>
-  </p:clrMapOvr>
-</p:notes>
-</file>
-
-<file path=ppt/notesSlides/notesSlide16.xml><?xml version="1.0" encoding="utf-8"?>
-<p:notes xmlns:a="http://schemas.openxmlformats.org/drawingml/2006/main" xmlns:r="http://schemas.openxmlformats.org/officeDocument/2006/relationships" xmlns:p="http://schemas.openxmlformats.org/presentationml/2006/main">
-  <p:cSld>
-    <p:spTree>
-      <p:nvGrpSpPr>
-        <p:cNvPr id="1" name=""/>
-        <p:cNvGrpSpPr/>
-        <p:nvPr/>
-      </p:nvGrpSpPr>
-      <p:grpSpPr>
-        <a:xfrm>
-          <a:off x="0" y="0"/>
-          <a:ext cx="0" cy="0"/>
-          <a:chOff x="0" y="0"/>
-          <a:chExt cx="0" cy="0"/>
-        </a:xfrm>
-      </p:grpSpPr>
-      <p:sp>
-        <p:nvSpPr>
-          <p:cNvPr id="2" name="Slide Image Placeholder 1"/>
-          <p:cNvSpPr>
-            <a:spLocks noGrp="1" noRot="1" noChangeAspect="1"/>
-          </p:cNvSpPr>
-          <p:nvPr>
-            <p:ph type="sldImg"/>
-          </p:nvPr>
-        </p:nvSpPr>
-        <p:spPr/>
-      </p:sp>
-      <p:sp>
-        <p:nvSpPr>
-          <p:cNvPr id="3" name="Notes Placeholder 2"/>
-          <p:cNvSpPr>
-            <a:spLocks noGrp="1"/>
-          </p:cNvSpPr>
-          <p:nvPr>
-            <p:ph type="body" idx="1"/>
-          </p:nvPr>
-        </p:nvSpPr>
-        <p:spPr/>
-        <p:txBody>
-          <a:bodyPr/>
-          <a:lstStyle/>
-          <a:p>
-            <a:r>
-              <a:rPr lang="en-US" dirty="0"/>
-              <a:t/>
-            </a:r>
-            <a:endParaRPr lang="en-US" dirty="0"/>
-          </a:p>
-        </p:txBody>
-      </p:sp>
-      <p:sp>
-        <p:nvSpPr>
-          <p:cNvPr id="4" name="Slide Number Placeholder 3"/>
-          <p:cNvSpPr>
-            <a:spLocks noGrp="1"/>
-          </p:cNvSpPr>
-          <p:nvPr>
-            <p:ph type="sldNum" sz="quarter" idx="10"/>
-          </p:nvPr>
-        </p:nvSpPr>
-        <p:spPr/>
-        <p:txBody>
-          <a:bodyPr/>
-          <a:lstStyle/>
-          <a:p>
-            <a:fld id="{F7021451-1387-4CA6-816F-3879F97B5CBC}" type="slidenum">
-              <a:rPr lang="en-US"/>
-              <a:t>16</a:t>
-            </a:fld>
-            <a:endParaRPr lang="en-US"/>
-          </a:p>
-        </p:txBody>
-      </p:sp>
-    </p:spTree>
-    <p:extLst>
-      <p:ext uri="{BB962C8B-B14F-4D97-AF65-F5344CB8AC3E}">
-        <p14:creationId xmlns:p14="http://schemas.microsoft.com/office/powerpoint/2010/main" val="1024086991"/>
-      </p:ext>
-    </p:extLst>
-  </p:cSld>
-  <p:clrMapOvr>
-    <a:masterClrMapping/>
-  </p:clrMapOvr>
-</p:notes>
-</file>
-
-<file path=ppt/notesSlides/notesSlide17.xml><?xml version="1.0" encoding="utf-8"?>
-<p:notes xmlns:a="http://schemas.openxmlformats.org/drawingml/2006/main" xmlns:r="http://schemas.openxmlformats.org/officeDocument/2006/relationships" xmlns:p="http://schemas.openxmlformats.org/presentationml/2006/main">
-  <p:cSld>
-    <p:spTree>
-      <p:nvGrpSpPr>
-        <p:cNvPr id="1" name=""/>
-        <p:cNvGrpSpPr/>
-        <p:nvPr/>
-      </p:nvGrpSpPr>
-      <p:grpSpPr>
-        <a:xfrm>
-          <a:off x="0" y="0"/>
-          <a:ext cx="0" cy="0"/>
-          <a:chOff x="0" y="0"/>
-          <a:chExt cx="0" cy="0"/>
-        </a:xfrm>
-      </p:grpSpPr>
-      <p:sp>
-        <p:nvSpPr>
-          <p:cNvPr id="2" name="Slide Image Placeholder 1"/>
-          <p:cNvSpPr>
-            <a:spLocks noGrp="1" noRot="1" noChangeAspect="1"/>
-          </p:cNvSpPr>
-          <p:nvPr>
-            <p:ph type="sldImg"/>
-          </p:nvPr>
-        </p:nvSpPr>
-        <p:spPr/>
-      </p:sp>
-      <p:sp>
-        <p:nvSpPr>
-          <p:cNvPr id="3" name="Notes Placeholder 2"/>
-          <p:cNvSpPr>
-            <a:spLocks noGrp="1"/>
-          </p:cNvSpPr>
-          <p:nvPr>
-            <p:ph type="body" idx="1"/>
-          </p:nvPr>
-        </p:nvSpPr>
-        <p:spPr/>
-        <p:txBody>
-          <a:bodyPr/>
-          <a:lstStyle/>
-          <a:p>
-            <a:r>
-              <a:rPr lang="en-US" dirty="0"/>
-              <a:t>polish-log
-(intermediate-content-polish feature 004) — populated during US2 polish pass.</a:t>
-            </a:r>
-            <a:endParaRPr lang="en-US" dirty="0"/>
-          </a:p>
-        </p:txBody>
-      </p:sp>
-      <p:sp>
-        <p:nvSpPr>
-          <p:cNvPr id="4" name="Slide Number Placeholder 3"/>
-          <p:cNvSpPr>
-            <a:spLocks noGrp="1"/>
-          </p:cNvSpPr>
-          <p:nvPr>
-            <p:ph type="sldNum" sz="quarter" idx="10"/>
-          </p:nvPr>
-        </p:nvSpPr>
-        <p:spPr/>
-        <p:txBody>
-          <a:bodyPr/>
-          <a:lstStyle/>
-          <a:p>
-            <a:fld id="{F7021451-1387-4CA6-816F-3879F97B5CBC}" type="slidenum">
-              <a:rPr lang="en-US"/>
-              <a:t>17</a:t>
             </a:fld>
             <a:endParaRPr lang="en-US"/>
           </a:p>
@@ -1311,7 +883,9 @@
           <a:p>
             <a:r>
               <a:rPr lang="en-US" dirty="0"/>
-              <a:t/>
+              <a:t>SPEAKER NOTES — slide 2 (course intro, 2 min)
+- Point at the schedule in README.md on your second screen.
+- Set expectations on breaks. Time is the scarce resource today — say it out loud.</a:t>
             </a:r>
             <a:endParaRPr lang="en-US" dirty="0"/>
           </a:p>
@@ -1399,7 +973,8 @@
           <a:p>
             <a:r>
               <a:rPr lang="en-US" dirty="0"/>
-              <a:t/>
+              <a:t>SPEAKER NOTES — slide 3 (instructor, 1 min)
+- Keep it short and credible. The students are here to build, not to hear a résumé.</a:t>
             </a:r>
             <a:endParaRPr lang="en-US" dirty="0"/>
           </a:p>
@@ -1487,7 +1062,9 @@
           <a:p>
             <a:r>
               <a:rPr lang="en-US" dirty="0"/>
-              <a:t/>
+              <a:t>SPEAKER NOTES — slide 4 (models, 2 min)
+- Don't quote exact prices — they move. Teach the SHAPE: Opus=think, Sonnet=do, Haiku=fast.
+- Most of today runs fine on Sonnet. Mention you'll call out where Opus earns its cost.</a:t>
             </a:r>
             <a:endParaRPr lang="en-US" dirty="0"/>
           </a:p>
@@ -1575,7 +1152,9 @@
           <a:p>
             <a:r>
               <a:rPr lang="en-US" dirty="0"/>
-              <a:t/>
+              <a:t>SPEAKER NOTES — slide 5 (theory, 3 min)
+- Draw the loop on the whiteboard while talking through it.
+- Anchor "engineer of record" — you sign the PR, not Claude.</a:t>
             </a:r>
             <a:endParaRPr lang="en-US" dirty="0"/>
           </a:p>
@@ -1663,7 +1242,8 @@
           <a:p>
             <a:r>
               <a:rPr lang="en-US" dirty="0"/>
-              <a:t/>
+              <a:t>SPEAKER NOTES — slide 6 (diagram, 1 min)
+- Trace the arrows once with your cursor; the cycle is the whole course in one picture.</a:t>
             </a:r>
             <a:endParaRPr lang="en-US" dirty="0"/>
           </a:p>
@@ -1751,7 +1331,8 @@
           <a:p>
             <a:r>
               <a:rPr lang="en-US" dirty="0"/>
-              <a:t/>
+              <a:t>SPEAKER NOTES — slide 6 (surfaces, 1 min)
+- One sentence each. Students only need to know: pick terminal or IDE today.</a:t>
             </a:r>
             <a:endParaRPr lang="en-US" dirty="0"/>
           </a:p>
@@ -1839,7 +1420,8 @@
           <a:p>
             <a:r>
               <a:rPr lang="en-US" dirty="0"/>
-              <a:t/>
+              <a:t>SPEAKER NOTES — slide 7 (slash commands, 1 min)
+- Don't read the table. Call out the 4 you'll use today: /init, /model, /review, /clear.</a:t>
             </a:r>
             <a:endParaRPr lang="en-US" dirty="0"/>
           </a:p>
@@ -1927,7 +1509,12 @@
           <a:p>
             <a:r>
               <a:rPr lang="en-US" dirty="0"/>
-              <a:t/>
+              <a:t>SPEAKER NOTES — slide 8 (common mistakes, 30 sec)
+- Flag the "verbatim copy" trap now — it costs students points later.
+Instructor cues:
+- Hard-cap this block at 20 min. Mindset only — no live installs.
+- Open from Claude Code on a known repo, not a slide.
+- Broken environment? Pair the student. Move on.</a:t>
             </a:r>
             <a:endParaRPr lang="en-US" dirty="0"/>
           </a:p>
@@ -2396,201 +1983,6 @@
 <file path=ppt/slides/slide12.xml><?xml version="1.0" encoding="utf-8"?>
 <p:sld xmlns:a="http://schemas.openxmlformats.org/drawingml/2006/main" xmlns:r="http://schemas.openxmlformats.org/officeDocument/2006/relationships" xmlns:p="http://schemas.openxmlformats.org/presentationml/2006/main">
   <p:cSld name="Slide 12">
-    <p:bg>
-      <p:bgPr>
-        <a:blipFill dpi="0" rotWithShape="1">
-          <a:blip r:embed="rId1">
-            <a:lum/>
-          </a:blip>
-          <a:srcRect/>
-          <a:stretch>
-            <a:fillRect/>
-          </a:stretch>
-        </a:blipFill>
-        <a:effectLst/>
-      </p:bgPr>
-    </p:bg>
-    <p:spTree>
-      <p:nvGrpSpPr>
-        <p:cNvPr id="1" name=""/>
-        <p:cNvGrpSpPr/>
-        <p:nvPr/>
-      </p:nvGrpSpPr>
-      <p:grpSpPr>
-        <a:xfrm>
-          <a:off x="0" y="0"/>
-          <a:ext cx="0" cy="0"/>
-          <a:chOff x="0" y="0"/>
-          <a:chExt cx="0" cy="0"/>
-        </a:xfrm>
-      </p:grpSpPr>
-    </p:spTree>
-  </p:cSld>
-  <p:clrMapOvr>
-    <a:masterClrMapping/>
-  </p:clrMapOvr>
-</p:sld>
-</file>
-
-<file path=ppt/slides/slide13.xml><?xml version="1.0" encoding="utf-8"?>
-<p:sld xmlns:a="http://schemas.openxmlformats.org/drawingml/2006/main" xmlns:r="http://schemas.openxmlformats.org/officeDocument/2006/relationships" xmlns:p="http://schemas.openxmlformats.org/presentationml/2006/main">
-  <p:cSld name="Slide 13">
-    <p:bg>
-      <p:bgPr>
-        <a:blipFill dpi="0" rotWithShape="1">
-          <a:blip r:embed="rId1">
-            <a:lum/>
-          </a:blip>
-          <a:srcRect/>
-          <a:stretch>
-            <a:fillRect/>
-          </a:stretch>
-        </a:blipFill>
-        <a:effectLst/>
-      </p:bgPr>
-    </p:bg>
-    <p:spTree>
-      <p:nvGrpSpPr>
-        <p:cNvPr id="1" name=""/>
-        <p:cNvGrpSpPr/>
-        <p:nvPr/>
-      </p:nvGrpSpPr>
-      <p:grpSpPr>
-        <a:xfrm>
-          <a:off x="0" y="0"/>
-          <a:ext cx="0" cy="0"/>
-          <a:chOff x="0" y="0"/>
-          <a:chExt cx="0" cy="0"/>
-        </a:xfrm>
-      </p:grpSpPr>
-    </p:spTree>
-  </p:cSld>
-  <p:clrMapOvr>
-    <a:masterClrMapping/>
-  </p:clrMapOvr>
-</p:sld>
-</file>
-
-<file path=ppt/slides/slide14.xml><?xml version="1.0" encoding="utf-8"?>
-<p:sld xmlns:a="http://schemas.openxmlformats.org/drawingml/2006/main" xmlns:r="http://schemas.openxmlformats.org/officeDocument/2006/relationships" xmlns:p="http://schemas.openxmlformats.org/presentationml/2006/main">
-  <p:cSld name="Slide 14">
-    <p:bg>
-      <p:bgPr>
-        <a:blipFill dpi="0" rotWithShape="1">
-          <a:blip r:embed="rId1">
-            <a:lum/>
-          </a:blip>
-          <a:srcRect/>
-          <a:stretch>
-            <a:fillRect/>
-          </a:stretch>
-        </a:blipFill>
-        <a:effectLst/>
-      </p:bgPr>
-    </p:bg>
-    <p:spTree>
-      <p:nvGrpSpPr>
-        <p:cNvPr id="1" name=""/>
-        <p:cNvGrpSpPr/>
-        <p:nvPr/>
-      </p:nvGrpSpPr>
-      <p:grpSpPr>
-        <a:xfrm>
-          <a:off x="0" y="0"/>
-          <a:ext cx="0" cy="0"/>
-          <a:chOff x="0" y="0"/>
-          <a:chExt cx="0" cy="0"/>
-        </a:xfrm>
-      </p:grpSpPr>
-    </p:spTree>
-  </p:cSld>
-  <p:clrMapOvr>
-    <a:masterClrMapping/>
-  </p:clrMapOvr>
-</p:sld>
-</file>
-
-<file path=ppt/slides/slide15.xml><?xml version="1.0" encoding="utf-8"?>
-<p:sld xmlns:a="http://schemas.openxmlformats.org/drawingml/2006/main" xmlns:r="http://schemas.openxmlformats.org/officeDocument/2006/relationships" xmlns:p="http://schemas.openxmlformats.org/presentationml/2006/main">
-  <p:cSld name="Slide 15">
-    <p:bg>
-      <p:bgPr>
-        <a:blipFill dpi="0" rotWithShape="1">
-          <a:blip r:embed="rId1">
-            <a:lum/>
-          </a:blip>
-          <a:srcRect/>
-          <a:stretch>
-            <a:fillRect/>
-          </a:stretch>
-        </a:blipFill>
-        <a:effectLst/>
-      </p:bgPr>
-    </p:bg>
-    <p:spTree>
-      <p:nvGrpSpPr>
-        <p:cNvPr id="1" name=""/>
-        <p:cNvGrpSpPr/>
-        <p:nvPr/>
-      </p:nvGrpSpPr>
-      <p:grpSpPr>
-        <a:xfrm>
-          <a:off x="0" y="0"/>
-          <a:ext cx="0" cy="0"/>
-          <a:chOff x="0" y="0"/>
-          <a:chExt cx="0" cy="0"/>
-        </a:xfrm>
-      </p:grpSpPr>
-    </p:spTree>
-  </p:cSld>
-  <p:clrMapOvr>
-    <a:masterClrMapping/>
-  </p:clrMapOvr>
-</p:sld>
-</file>
-
-<file path=ppt/slides/slide16.xml><?xml version="1.0" encoding="utf-8"?>
-<p:sld xmlns:a="http://schemas.openxmlformats.org/drawingml/2006/main" xmlns:r="http://schemas.openxmlformats.org/officeDocument/2006/relationships" xmlns:p="http://schemas.openxmlformats.org/presentationml/2006/main">
-  <p:cSld name="Slide 16">
-    <p:bg>
-      <p:bgPr>
-        <a:blipFill dpi="0" rotWithShape="1">
-          <a:blip r:embed="rId1">
-            <a:lum/>
-          </a:blip>
-          <a:srcRect/>
-          <a:stretch>
-            <a:fillRect/>
-          </a:stretch>
-        </a:blipFill>
-        <a:effectLst/>
-      </p:bgPr>
-    </p:bg>
-    <p:spTree>
-      <p:nvGrpSpPr>
-        <p:cNvPr id="1" name=""/>
-        <p:cNvGrpSpPr/>
-        <p:nvPr/>
-      </p:nvGrpSpPr>
-      <p:grpSpPr>
-        <a:xfrm>
-          <a:off x="0" y="0"/>
-          <a:ext cx="0" cy="0"/>
-          <a:chOff x="0" y="0"/>
-          <a:chExt cx="0" cy="0"/>
-        </a:xfrm>
-      </p:grpSpPr>
-    </p:spTree>
-  </p:cSld>
-  <p:clrMapOvr>
-    <a:masterClrMapping/>
-  </p:clrMapOvr>
-</p:sld>
-</file>
-
-<file path=ppt/slides/slide17.xml><?xml version="1.0" encoding="utf-8"?>
-<p:sld xmlns:a="http://schemas.openxmlformats.org/drawingml/2006/main" xmlns:r="http://schemas.openxmlformats.org/officeDocument/2006/relationships" xmlns:p="http://schemas.openxmlformats.org/presentationml/2006/main">
-  <p:cSld name="Slide 17">
     <p:bg>
       <p:bgPr>
         <a:blipFill dpi="0" rotWithShape="1">

</xml_diff>